<commit_message>
Slides: sd-13-008 keeps to the lesson's wording
Slides 1 and 3-6 no longer add a candidate count, a community criterion,
a one-cluster pilot, review conditions or example layer names; the badged
PPTX is re-exported.

Co-Authored-By: Claude Opus 5.5 <noreply@anthropic.com>
Claude-Session: https://claude.ai/code/session_01TQmrJYLm4GPgtXpQaEk7ey
</commit_message>
<xml_diff>
--- a/system-design-101/vi/lessons/sd-13-008/slides/sd-13-008.pptx
+++ b/system-design-101/vi/lessons/sd-13-008/slides/sd-13-008.pptx
@@ -2555,7 +2555,18 @@
                 <a:ea typeface="Be Vietnam Pro" pitchFamily="34" charset="-122"/>
                 <a:cs typeface="Be Vietnam Pro" pitchFamily="34" charset="-120"/>
               </a:rPr>
-              <a:t> sánh 2–3</a:t>
+              <a:t> sánh</a:t>
+            </a:r>
+            <a:r>
+              <a:rPr lang="en-US" sz="2550" b="1" dirty="0" spc="-13" kern="0">
+                <a:solidFill>
+                  <a:srgbClr val="F3EEE3"/>
+                </a:solidFill>
+                <a:latin typeface="Be Vietnam Pro" pitchFamily="34" charset="0"/>
+                <a:ea typeface="Be Vietnam Pro" pitchFamily="34" charset="-122"/>
+                <a:cs typeface="Be Vietnam Pro" pitchFamily="34" charset="-120"/>
+              </a:rPr>
+              <a:t> vài</a:t>
             </a:r>
             <a:r>
               <a:rPr lang="en-US" sz="2550" b="1" dirty="0" spc="29" kern="0">
@@ -2569,7 +2580,7 @@
               <a:t> ứng</a:t>
             </a:r>
             <a:r>
-              <a:rPr lang="en-US" sz="2550" b="1" dirty="0" spc="-2" kern="0">
+              <a:rPr lang="en-US" sz="2550" b="1" dirty="0" spc="-1" kern="0">
                 <a:solidFill>
                   <a:srgbClr val="F3EEE3"/>
                 </a:solidFill>
@@ -5385,6 +5396,50 @@
               <a:buNone/>
             </a:pPr>
             <a:r>
+              <a:rPr lang="en-US" sz="2550" dirty="0" spc="4" kern="0">
+                <a:solidFill>
+                  <a:srgbClr val="E4E1D8"/>
+                </a:solidFill>
+                <a:latin typeface="Be Vietnam Pro" pitchFamily="34" charset="0"/>
+                <a:ea typeface="Be Vietnam Pro" pitchFamily="34" charset="-122"/>
+                <a:cs typeface="Be Vietnam Pro" pitchFamily="34" charset="-120"/>
+              </a:rPr>
+              <a:t>Nêu</a:t>
+            </a:r>
+            <a:r>
+              <a:rPr lang="en-US" sz="2550" dirty="0" spc="-34" kern="0">
+                <a:solidFill>
+                  <a:srgbClr val="E4E1D8"/>
+                </a:solidFill>
+                <a:latin typeface="Be Vietnam Pro" pitchFamily="34" charset="0"/>
+                <a:ea typeface="Be Vietnam Pro" pitchFamily="34" charset="-122"/>
+                <a:cs typeface="Be Vietnam Pro" pitchFamily="34" charset="-120"/>
+              </a:rPr>
+              <a:t> rõ</a:t>
+            </a:r>
+            <a:r>
+              <a:rPr lang="en-US" sz="2550" dirty="0" spc="-4" kern="0">
+                <a:solidFill>
+                  <a:srgbClr val="E4E1D8"/>
+                </a:solidFill>
+                <a:latin typeface="Be Vietnam Pro" pitchFamily="34" charset="0"/>
+                <a:ea typeface="Be Vietnam Pro" pitchFamily="34" charset="-122"/>
+                <a:cs typeface="Be Vietnam Pro" pitchFamily="34" charset="-120"/>
+              </a:rPr>
+              <a:t> việc</a:t>
+            </a:r>
+            <a:r>
+              <a:rPr lang="en-US" sz="2550" dirty="0" spc="1" kern="0">
+                <a:solidFill>
+                  <a:srgbClr val="E4E1D8"/>
+                </a:solidFill>
+                <a:latin typeface="Be Vietnam Pro" pitchFamily="34" charset="0"/>
+                <a:ea typeface="Be Vietnam Pro" pitchFamily="34" charset="-122"/>
+                <a:cs typeface="Be Vietnam Pro" pitchFamily="34" charset="-120"/>
+              </a:rPr>
+              <a:t> cần</a:t>
+            </a:r>
+            <a:r>
               <a:rPr lang="en-US" sz="2550" dirty="0" spc="0" kern="0">
                 <a:solidFill>
                   <a:srgbClr val="E4E1D8"/>
@@ -5393,10 +5448,10 @@
                 <a:ea typeface="Be Vietnam Pro" pitchFamily="34" charset="-122"/>
                 <a:cs typeface="Be Vietnam Pro" pitchFamily="34" charset="-120"/>
               </a:rPr>
-              <a:t>Mạng,</a:t>
-            </a:r>
-            <a:r>
-              <a:rPr lang="en-US" sz="2550" dirty="0" spc="-3" kern="0">
+              <a:t> giải</a:t>
+            </a:r>
+            <a:r>
+              <a:rPr lang="en-US" sz="2550" dirty="0" spc="-14" kern="0">
                 <a:solidFill>
                   <a:srgbClr val="E4E1D8"/>
                 </a:solidFill>
@@ -5404,40 +5459,7 @@
                 <a:ea typeface="Be Vietnam Pro" pitchFamily="34" charset="-122"/>
                 <a:cs typeface="Be Vietnam Pro" pitchFamily="34" charset="-120"/>
               </a:rPr>
-              <a:t> bảo</a:t>
-            </a:r>
-            <a:r>
-              <a:rPr lang="en-US" sz="2550" dirty="0" spc="-9" kern="0">
-                <a:solidFill>
-                  <a:srgbClr val="E4E1D8"/>
-                </a:solidFill>
-                <a:latin typeface="Be Vietnam Pro" pitchFamily="34" charset="0"/>
-                <a:ea typeface="Be Vietnam Pro" pitchFamily="34" charset="-122"/>
-                <a:cs typeface="Be Vietnam Pro" pitchFamily="34" charset="-120"/>
-              </a:rPr>
-              <a:t> mật,</a:t>
-            </a:r>
-            <a:r>
-              <a:rPr lang="en-US" sz="2550" dirty="0" spc="1" kern="0">
-                <a:solidFill>
-                  <a:srgbClr val="E4E1D8"/>
-                </a:solidFill>
-                <a:latin typeface="Be Vietnam Pro" pitchFamily="34" charset="0"/>
-                <a:ea typeface="Be Vietnam Pro" pitchFamily="34" charset="-122"/>
-                <a:cs typeface="Be Vietnam Pro" pitchFamily="34" charset="-120"/>
-              </a:rPr>
-              <a:t> quan</a:t>
-            </a:r>
-            <a:r>
-              <a:rPr lang="en-US" sz="2550" dirty="0" spc="-24" kern="0">
-                <a:solidFill>
-                  <a:srgbClr val="E4E1D8"/>
-                </a:solidFill>
-                <a:latin typeface="Be Vietnam Pro" pitchFamily="34" charset="0"/>
-                <a:ea typeface="Be Vietnam Pro" pitchFamily="34" charset="-122"/>
-                <a:cs typeface="Be Vietnam Pro" pitchFamily="34" charset="-120"/>
-              </a:rPr>
-              <a:t> sát...</a:t>
+              <a:t> quyết.</a:t>
             </a:r>
             <a:endParaRPr lang="en-US" sz="2550" dirty="0"/>
           </a:p>
@@ -5618,7 +5640,7 @@
               <a:buNone/>
             </a:pPr>
             <a:r>
-              <a:rPr lang="en-US" sz="2700" b="1" dirty="0" spc="4" kern="0">
+              <a:rPr lang="en-US" sz="2700" b="1" dirty="0" spc="-24" kern="0">
                 <a:solidFill>
                   <a:srgbClr val="F3EEE3"/>
                 </a:solidFill>
@@ -5626,10 +5648,10 @@
                 <a:ea typeface="Be Vietnam Pro" pitchFamily="34" charset="-122"/>
                 <a:cs typeface="Be Vietnam Pro" pitchFamily="34" charset="-120"/>
               </a:rPr>
-              <a:t>Quan</a:t>
-            </a:r>
-            <a:r>
-              <a:rPr lang="en-US" sz="2700" b="1" dirty="0" spc="-9" kern="0">
+              <a:t>Lớp</a:t>
+            </a:r>
+            <a:r>
+              <a:rPr lang="en-US" sz="2700" b="1" dirty="0" spc="-2" kern="0">
                 <a:solidFill>
                   <a:srgbClr val="F3EEE3"/>
                 </a:solidFill>
@@ -5637,7 +5659,18 @@
                 <a:ea typeface="Be Vietnam Pro" pitchFamily="34" charset="-122"/>
                 <a:cs typeface="Be Vietnam Pro" pitchFamily="34" charset="-120"/>
               </a:rPr>
-              <a:t> sát</a:t>
+              <a:t> việc</a:t>
+            </a:r>
+            <a:r>
+              <a:rPr lang="en-US" sz="2700" b="1" dirty="0" spc="-1" kern="0">
+                <a:solidFill>
+                  <a:srgbClr val="F3EEE3"/>
+                </a:solidFill>
+                <a:latin typeface="Be Vietnam Pro" pitchFamily="34" charset="0"/>
+                <a:ea typeface="Be Vietnam Pro" pitchFamily="34" charset="-122"/>
+                <a:cs typeface="Be Vietnam Pro" pitchFamily="34" charset="-120"/>
+              </a:rPr>
+              <a:t> A</a:t>
             </a:r>
             <a:endParaRPr lang="en-US" sz="2700" dirty="0"/>
           </a:p>
@@ -5677,7 +5710,7 @@
               <a:buNone/>
             </a:pPr>
             <a:r>
-              <a:rPr lang="en-US" sz="2700" b="1" dirty="0" spc="7" kern="0">
+              <a:rPr lang="en-US" sz="2700" b="1" dirty="0" spc="-24" kern="0">
                 <a:solidFill>
                   <a:srgbClr val="F3EEE3"/>
                 </a:solidFill>
@@ -5685,10 +5718,10 @@
                 <a:ea typeface="Be Vietnam Pro" pitchFamily="34" charset="-122"/>
                 <a:cs typeface="Be Vietnam Pro" pitchFamily="34" charset="-120"/>
               </a:rPr>
-              <a:t>Bảo</a:t>
-            </a:r>
-            <a:r>
-              <a:rPr lang="en-US" sz="2700" b="1" dirty="0" spc="-12" kern="0">
+              <a:t>Lớp</a:t>
+            </a:r>
+            <a:r>
+              <a:rPr lang="en-US" sz="2700" b="1" dirty="0" spc="-2" kern="0">
                 <a:solidFill>
                   <a:srgbClr val="F3EEE3"/>
                 </a:solidFill>
@@ -5696,7 +5729,18 @@
                 <a:ea typeface="Be Vietnam Pro" pitchFamily="34" charset="-122"/>
                 <a:cs typeface="Be Vietnam Pro" pitchFamily="34" charset="-120"/>
               </a:rPr>
-              <a:t> mật</a:t>
+              <a:t> việc</a:t>
+            </a:r>
+            <a:r>
+              <a:rPr lang="en-US" sz="2700" b="1" dirty="0" spc="-1" kern="0">
+                <a:solidFill>
+                  <a:srgbClr val="F3EEE3"/>
+                </a:solidFill>
+                <a:latin typeface="Be Vietnam Pro" pitchFamily="34" charset="0"/>
+                <a:ea typeface="Be Vietnam Pro" pitchFamily="34" charset="-122"/>
+                <a:cs typeface="Be Vietnam Pro" pitchFamily="34" charset="-120"/>
+              </a:rPr>
+              <a:t> B</a:t>
             </a:r>
             <a:endParaRPr lang="en-US" sz="2700" dirty="0"/>
           </a:p>
@@ -5736,7 +5780,7 @@
               <a:buNone/>
             </a:pPr>
             <a:r>
-              <a:rPr lang="en-US" sz="2700" b="1" dirty="0" spc="-4" kern="0">
+              <a:rPr lang="en-US" sz="2700" b="1" dirty="0" spc="-24" kern="0">
                 <a:solidFill>
                   <a:srgbClr val="F3EEE3"/>
                 </a:solidFill>
@@ -5744,7 +5788,29 @@
                 <a:ea typeface="Be Vietnam Pro" pitchFamily="34" charset="-122"/>
                 <a:cs typeface="Be Vietnam Pro" pitchFamily="34" charset="-120"/>
               </a:rPr>
-              <a:t>Mạng</a:t>
+              <a:t>Lớp</a:t>
+            </a:r>
+            <a:r>
+              <a:rPr lang="en-US" sz="2700" b="1" dirty="0" spc="-2" kern="0">
+                <a:solidFill>
+                  <a:srgbClr val="F3EEE3"/>
+                </a:solidFill>
+                <a:latin typeface="Be Vietnam Pro" pitchFamily="34" charset="0"/>
+                <a:ea typeface="Be Vietnam Pro" pitchFamily="34" charset="-122"/>
+                <a:cs typeface="Be Vietnam Pro" pitchFamily="34" charset="-120"/>
+              </a:rPr>
+              <a:t> việc</a:t>
+            </a:r>
+            <a:r>
+              <a:rPr lang="en-US" sz="2700" b="1" dirty="0" spc="1" kern="0">
+                <a:solidFill>
+                  <a:srgbClr val="F3EEE3"/>
+                </a:solidFill>
+                <a:latin typeface="Be Vietnam Pro" pitchFamily="34" charset="0"/>
+                <a:ea typeface="Be Vietnam Pro" pitchFamily="34" charset="-122"/>
+                <a:cs typeface="Be Vietnam Pro" pitchFamily="34" charset="-120"/>
+              </a:rPr>
+              <a:t> C</a:t>
             </a:r>
             <a:endParaRPr lang="en-US" sz="2700" dirty="0"/>
           </a:p>
@@ -6453,7 +6519,7 @@
               <a:t>So sánh</a:t>
             </a:r>
             <a:r>
-              <a:rPr lang="en-US" sz="7200" dirty="0" spc="-62" kern="0">
+              <a:rPr lang="en-US" sz="7200" dirty="0" spc="-58" kern="0">
                 <a:solidFill>
                   <a:srgbClr val="14161C"/>
                 </a:solidFill>
@@ -6461,7 +6527,7 @@
                 <a:ea typeface="Bricolage Grotesque ExtraBold" pitchFamily="34" charset="-122"/>
                 <a:cs typeface="Bricolage Grotesque ExtraBold" pitchFamily="34" charset="-120"/>
               </a:rPr>
-              <a:t> 2–3</a:t>
+              <a:t> vài</a:t>
             </a:r>
             <a:r>
               <a:rPr lang="en-US" sz="7200" dirty="0" spc="11" kern="0">
@@ -6726,7 +6792,7 @@
                         <a:buNone/>
                       </a:pPr>
                       <a:r>
-                        <a:rPr lang="en-US" sz="2550" b="1" dirty="0" spc="-3" kern="0">
+                        <a:rPr lang="en-US" sz="2550" b="1" dirty="0" spc="-50" kern="0">
                           <a:solidFill>
                             <a:srgbClr val="14161C"/>
                           </a:solidFill>
@@ -6734,18 +6800,7 @@
                           <a:ea typeface="Be Vietnam Pro" pitchFamily="34" charset="-122"/>
                           <a:cs typeface="Be Vietnam Pro" pitchFamily="34" charset="-120"/>
                         </a:rPr>
-                        <a:t>Ứng</a:t>
-                      </a:r>
-                      <a:r>
-                        <a:rPr lang="en-US" sz="2550" b="1" dirty="0" spc="-1" kern="0">
-                          <a:solidFill>
-                            <a:srgbClr val="14161C"/>
-                          </a:solidFill>
-                          <a:latin typeface="Be Vietnam Pro" pitchFamily="34" charset="0"/>
-                          <a:ea typeface="Be Vietnam Pro" pitchFamily="34" charset="-122"/>
-                          <a:cs typeface="Be Vietnam Pro" pitchFamily="34" charset="-120"/>
-                        </a:rPr>
-                        <a:t> viên C</a:t>
+                        <a:t>...</a:t>
                       </a:r>
                       <a:endParaRPr lang="en-US" sz="1200" dirty="0"/>
                     </a:p>
@@ -6788,7 +6843,7 @@
                         <a:buNone/>
                       </a:pPr>
                       <a:r>
-                        <a:rPr lang="en-US" sz="2550" dirty="0" spc="-2" kern="0">
+                        <a:rPr lang="en-US" sz="2550" dirty="0" spc="11" kern="0">
                           <a:solidFill>
                             <a:srgbClr val="14161C"/>
                           </a:solidFill>
@@ -6796,7 +6851,7 @@
                           <a:ea typeface="Be Vietnam Pro" pitchFamily="34" charset="-122"/>
                           <a:cs typeface="Be Vietnam Pro" pitchFamily="34" charset="-120"/>
                         </a:rPr>
-                        <a:t>Độ</a:t>
+                        <a:t>Mức</a:t>
                       </a:r>
                       <a:r>
                         <a:rPr lang="en-US" sz="2550" dirty="0" spc="5" kern="0">
@@ -7275,7 +7330,7 @@
                         <a:buNone/>
                       </a:pPr>
                       <a:r>
-                        <a:rPr lang="en-US" sz="2550" dirty="0" spc="1" kern="0">
+                        <a:rPr lang="en-US" sz="2550" dirty="0" spc="9" kern="0">
                           <a:solidFill>
                             <a:srgbClr val="14161C"/>
                           </a:solidFill>
@@ -7283,10 +7338,10 @@
                           <a:ea typeface="Be Vietnam Pro" pitchFamily="34" charset="-122"/>
                           <a:cs typeface="Be Vietnam Pro" pitchFamily="34" charset="-120"/>
                         </a:rPr>
-                        <a:t>Cộng</a:t>
+                        <a:t>Sức</a:t>
                       </a:r>
                       <a:r>
-                        <a:rPr lang="en-US" sz="2550" dirty="0" spc="10" kern="0">
+                        <a:rPr lang="en-US" sz="2550" dirty="0" spc="5" kern="0">
                           <a:solidFill>
                             <a:srgbClr val="14161C"/>
                           </a:solidFill>
@@ -7294,223 +7349,7 @@
                           <a:ea typeface="Be Vietnam Pro" pitchFamily="34" charset="-122"/>
                           <a:cs typeface="Be Vietnam Pro" pitchFamily="34" charset="-120"/>
                         </a:rPr>
-                        <a:t> đồng</a:t>
-                      </a:r>
-                      <a:endParaRPr lang="en-US" sz="1200" dirty="0"/>
-                    </a:p>
-                  </a:txBody>
-                  <a:tcPr marL="304800" marR="304800" marT="304800" marB="304800" anchor="ctr">
-                    <a:lnL w="0" cap="flat" cmpd="sng" algn="ctr">
-                      <a:noFill/>
-                    </a:lnL>
-                    <a:lnR w="0" cap="flat" cmpd="sng" algn="ctr">
-                      <a:noFill/>
-                    </a:lnR>
-                    <a:lnT w="19050" cap="flat" cmpd="sng" algn="ctr">
-                      <a:solidFill>
-                        <a:srgbClr val="DDD5C1"/>
-                      </a:solidFill>
-                      <a:prstDash val="solid"/>
-                      <a:round/>
-                      <a:headEnd type="none" w="med" len="med"/>
-                      <a:tailEnd type="none" w="med" len="med"/>
-                    </a:lnT>
-                    <a:lnB w="0" cap="flat" cmpd="sng" algn="ctr">
-                      <a:noFill/>
-                    </a:lnB>
-                    <a:solidFill>
-                      <a:srgbClr val="FBF8F2"/>
-                    </a:solidFill>
-                  </a:tcPr>
-                </a:tc>
-                <a:tc>
-                  <a:txBody>
-                    <a:bodyPr/>
-                    <a:lstStyle/>
-                    <a:p>
-                      <a:pPr algn="ctr" indent="0" marL="0">
-                        <a:lnSpc>
-                          <a:spcPts val="3060"/>
-                        </a:lnSpc>
-                        <a:buNone/>
-                      </a:pPr>
-                      <a:r>
-                        <a:rPr lang="en-US" sz="2550" dirty="0" spc="-1" kern="0">
-                          <a:solidFill>
-                            <a:srgbClr val="14161C"/>
-                          </a:solidFill>
-                          <a:latin typeface="Be Vietnam Pro" pitchFamily="34" charset="0"/>
-                          <a:ea typeface="Be Vietnam Pro" pitchFamily="34" charset="-122"/>
-                          <a:cs typeface="Be Vietnam Pro" pitchFamily="34" charset="-120"/>
-                        </a:rPr>
-                        <a:t>?</a:t>
-                      </a:r>
-                      <a:endParaRPr lang="en-US" sz="1200" dirty="0"/>
-                    </a:p>
-                  </a:txBody>
-                  <a:tcPr marL="76200" marR="76200" marT="76200" marB="76200" anchor="ctr">
-                    <a:lnL w="19050" cap="flat" cmpd="sng" algn="ctr">
-                      <a:solidFill>
-                        <a:srgbClr val="DDD5C1"/>
-                      </a:solidFill>
-                      <a:prstDash val="solid"/>
-                      <a:round/>
-                      <a:headEnd type="none" w="med" len="med"/>
-                      <a:tailEnd type="none" w="med" len="med"/>
-                    </a:lnL>
-                    <a:lnR w="0" cap="flat" cmpd="sng" algn="ctr">
-                      <a:noFill/>
-                    </a:lnR>
-                    <a:lnT w="19050" cap="flat" cmpd="sng" algn="ctr">
-                      <a:solidFill>
-                        <a:srgbClr val="DDD5C1"/>
-                      </a:solidFill>
-                      <a:prstDash val="solid"/>
-                      <a:round/>
-                      <a:headEnd type="none" w="med" len="med"/>
-                      <a:tailEnd type="none" w="med" len="med"/>
-                    </a:lnT>
-                    <a:lnB w="0" cap="flat" cmpd="sng" algn="ctr">
-                      <a:noFill/>
-                    </a:lnB>
-                    <a:solidFill>
-                      <a:srgbClr val="FBF8F2"/>
-                    </a:solidFill>
-                  </a:tcPr>
-                </a:tc>
-                <a:tc>
-                  <a:txBody>
-                    <a:bodyPr/>
-                    <a:lstStyle/>
-                    <a:p>
-                      <a:pPr algn="ctr" indent="0" marL="0">
-                        <a:lnSpc>
-                          <a:spcPts val="3060"/>
-                        </a:lnSpc>
-                        <a:buNone/>
-                      </a:pPr>
-                      <a:r>
-                        <a:rPr lang="en-US" sz="2550" dirty="0" spc="-1" kern="0">
-                          <a:solidFill>
-                            <a:srgbClr val="14161C"/>
-                          </a:solidFill>
-                          <a:latin typeface="Be Vietnam Pro" pitchFamily="34" charset="0"/>
-                          <a:ea typeface="Be Vietnam Pro" pitchFamily="34" charset="-122"/>
-                          <a:cs typeface="Be Vietnam Pro" pitchFamily="34" charset="-120"/>
-                        </a:rPr>
-                        <a:t>?</a:t>
-                      </a:r>
-                      <a:endParaRPr lang="en-US" sz="1200" dirty="0"/>
-                    </a:p>
-                  </a:txBody>
-                  <a:tcPr marL="76200" marR="76200" marT="76200" marB="76200" anchor="ctr">
-                    <a:lnL w="19050" cap="flat" cmpd="sng" algn="ctr">
-                      <a:solidFill>
-                        <a:srgbClr val="DDD5C1"/>
-                      </a:solidFill>
-                      <a:prstDash val="solid"/>
-                      <a:round/>
-                      <a:headEnd type="none" w="med" len="med"/>
-                      <a:tailEnd type="none" w="med" len="med"/>
-                    </a:lnL>
-                    <a:lnR w="0" cap="flat" cmpd="sng" algn="ctr">
-                      <a:noFill/>
-                    </a:lnR>
-                    <a:lnT w="19050" cap="flat" cmpd="sng" algn="ctr">
-                      <a:solidFill>
-                        <a:srgbClr val="DDD5C1"/>
-                      </a:solidFill>
-                      <a:prstDash val="solid"/>
-                      <a:round/>
-                      <a:headEnd type="none" w="med" len="med"/>
-                      <a:tailEnd type="none" w="med" len="med"/>
-                    </a:lnT>
-                    <a:lnB w="0" cap="flat" cmpd="sng" algn="ctr">
-                      <a:noFill/>
-                    </a:lnB>
-                    <a:solidFill>
-                      <a:srgbClr val="FBF8F2"/>
-                    </a:solidFill>
-                  </a:tcPr>
-                </a:tc>
-                <a:tc>
-                  <a:txBody>
-                    <a:bodyPr/>
-                    <a:lstStyle/>
-                    <a:p>
-                      <a:pPr algn="ctr" indent="0" marL="0">
-                        <a:lnSpc>
-                          <a:spcPts val="3060"/>
-                        </a:lnSpc>
-                        <a:buNone/>
-                      </a:pPr>
-                      <a:r>
-                        <a:rPr lang="en-US" sz="2550" dirty="0" spc="-1" kern="0">
-                          <a:solidFill>
-                            <a:srgbClr val="14161C"/>
-                          </a:solidFill>
-                          <a:latin typeface="Be Vietnam Pro" pitchFamily="34" charset="0"/>
-                          <a:ea typeface="Be Vietnam Pro" pitchFamily="34" charset="-122"/>
-                          <a:cs typeface="Be Vietnam Pro" pitchFamily="34" charset="-120"/>
-                        </a:rPr>
-                        <a:t>?</a:t>
-                      </a:r>
-                      <a:endParaRPr lang="en-US" sz="1200" dirty="0"/>
-                    </a:p>
-                  </a:txBody>
-                  <a:tcPr marL="76200" marR="76200" marT="76200" marB="76200" anchor="ctr">
-                    <a:lnL w="19050" cap="flat" cmpd="sng" algn="ctr">
-                      <a:solidFill>
-                        <a:srgbClr val="DDD5C1"/>
-                      </a:solidFill>
-                      <a:prstDash val="solid"/>
-                      <a:round/>
-                      <a:headEnd type="none" w="med" len="med"/>
-                      <a:tailEnd type="none" w="med" len="med"/>
-                    </a:lnL>
-                    <a:lnR w="0" cap="flat" cmpd="sng" algn="ctr">
-                      <a:noFill/>
-                    </a:lnR>
-                    <a:lnT w="19050" cap="flat" cmpd="sng" algn="ctr">
-                      <a:solidFill>
-                        <a:srgbClr val="DDD5C1"/>
-                      </a:solidFill>
-                      <a:prstDash val="solid"/>
-                      <a:round/>
-                      <a:headEnd type="none" w="med" len="med"/>
-                      <a:tailEnd type="none" w="med" len="med"/>
-                    </a:lnT>
-                    <a:lnB w="0" cap="flat" cmpd="sng" algn="ctr">
-                      <a:noFill/>
-                    </a:lnB>
-                    <a:solidFill>
-                      <a:srgbClr val="FBF8F2"/>
-                    </a:solidFill>
-                  </a:tcPr>
-                </a:tc>
-              </a:tr>
-              <a:tr h="1104900">
-                <a:tc>
-                  <a:txBody>
-                    <a:bodyPr/>
-                    <a:lstStyle/>
-                    <a:p>
-                      <a:pPr algn="l" indent="0" marL="0">
-                        <a:lnSpc>
-                          <a:spcPts val="3060"/>
-                        </a:lnSpc>
-                        <a:buNone/>
-                      </a:pPr>
-                      <a:r>
-                        <a:rPr lang="en-US" sz="2550" dirty="0" spc="0" kern="0">
-                          <a:solidFill>
-                            <a:srgbClr val="14161C"/>
-                          </a:solidFill>
-                          <a:latin typeface="Be Vietnam Pro" pitchFamily="34" charset="0"/>
-                          <a:ea typeface="Be Vietnam Pro" pitchFamily="34" charset="-122"/>
-                          <a:cs typeface="Be Vietnam Pro" pitchFamily="34" charset="-120"/>
-                        </a:rPr>
-                        <a:t>Chi phí</a:t>
+                        <a:t> người</a:t>
                       </a:r>
                       <a:r>
                         <a:rPr lang="en-US" sz="2550" dirty="0" spc="-14" kern="0">
@@ -7727,6 +7566,222 @@
                   </a:tcPr>
                 </a:tc>
               </a:tr>
+              <a:tr h="1104900">
+                <a:tc>
+                  <a:txBody>
+                    <a:bodyPr/>
+                    <a:lstStyle/>
+                    <a:p>
+                      <a:pPr algn="l" indent="0" marL="0">
+                        <a:lnSpc>
+                          <a:spcPts val="3060"/>
+                        </a:lnSpc>
+                        <a:buNone/>
+                      </a:pPr>
+                      <a:r>
+                        <a:rPr lang="en-US" sz="2550" dirty="0" kern="0">
+                          <a:solidFill>
+                            <a:srgbClr val="14161C"/>
+                          </a:solidFill>
+                          <a:latin typeface="Be Vietnam Pro" pitchFamily="34" charset="0"/>
+                          <a:ea typeface="Be Vietnam Pro" pitchFamily="34" charset="-122"/>
+                          <a:cs typeface="Be Vietnam Pro" pitchFamily="34" charset="-120"/>
+                        </a:rPr>
+                        <a:t>Chi phí ẩn</a:t>
+                      </a:r>
+                      <a:endParaRPr lang="en-US" sz="1200" dirty="0"/>
+                    </a:p>
+                  </a:txBody>
+                  <a:tcPr marL="304800" marR="304800" marT="304800" marB="304800" anchor="ctr">
+                    <a:lnL w="0" cap="flat" cmpd="sng" algn="ctr">
+                      <a:noFill/>
+                    </a:lnL>
+                    <a:lnR w="0" cap="flat" cmpd="sng" algn="ctr">
+                      <a:noFill/>
+                    </a:lnR>
+                    <a:lnT w="19050" cap="flat" cmpd="sng" algn="ctr">
+                      <a:solidFill>
+                        <a:srgbClr val="DDD5C1"/>
+                      </a:solidFill>
+                      <a:prstDash val="solid"/>
+                      <a:round/>
+                      <a:headEnd type="none" w="med" len="med"/>
+                      <a:tailEnd type="none" w="med" len="med"/>
+                    </a:lnT>
+                    <a:lnB w="0" cap="flat" cmpd="sng" algn="ctr">
+                      <a:noFill/>
+                    </a:lnB>
+                    <a:solidFill>
+                      <a:srgbClr val="FBF8F2"/>
+                    </a:solidFill>
+                  </a:tcPr>
+                </a:tc>
+                <a:tc>
+                  <a:txBody>
+                    <a:bodyPr/>
+                    <a:lstStyle/>
+                    <a:p>
+                      <a:pPr algn="ctr" indent="0" marL="0">
+                        <a:lnSpc>
+                          <a:spcPts val="3060"/>
+                        </a:lnSpc>
+                        <a:buNone/>
+                      </a:pPr>
+                      <a:r>
+                        <a:rPr lang="en-US" sz="2550" dirty="0" spc="-1" kern="0">
+                          <a:solidFill>
+                            <a:srgbClr val="14161C"/>
+                          </a:solidFill>
+                          <a:latin typeface="Be Vietnam Pro" pitchFamily="34" charset="0"/>
+                          <a:ea typeface="Be Vietnam Pro" pitchFamily="34" charset="-122"/>
+                          <a:cs typeface="Be Vietnam Pro" pitchFamily="34" charset="-120"/>
+                        </a:rPr>
+                        <a:t>?</a:t>
+                      </a:r>
+                      <a:endParaRPr lang="en-US" sz="1200" dirty="0"/>
+                    </a:p>
+                  </a:txBody>
+                  <a:tcPr marL="76200" marR="76200" marT="76200" marB="76200" anchor="ctr">
+                    <a:lnL w="19050" cap="flat" cmpd="sng" algn="ctr">
+                      <a:solidFill>
+                        <a:srgbClr val="DDD5C1"/>
+                      </a:solidFill>
+                      <a:prstDash val="solid"/>
+                      <a:round/>
+                      <a:headEnd type="none" w="med" len="med"/>
+                      <a:tailEnd type="none" w="med" len="med"/>
+                    </a:lnL>
+                    <a:lnR w="0" cap="flat" cmpd="sng" algn="ctr">
+                      <a:noFill/>
+                    </a:lnR>
+                    <a:lnT w="19050" cap="flat" cmpd="sng" algn="ctr">
+                      <a:solidFill>
+                        <a:srgbClr val="DDD5C1"/>
+                      </a:solidFill>
+                      <a:prstDash val="solid"/>
+                      <a:round/>
+                      <a:headEnd type="none" w="med" len="med"/>
+                      <a:tailEnd type="none" w="med" len="med"/>
+                    </a:lnT>
+                    <a:lnB w="0" cap="flat" cmpd="sng" algn="ctr">
+                      <a:noFill/>
+                    </a:lnB>
+                    <a:solidFill>
+                      <a:srgbClr val="FBF8F2"/>
+                    </a:solidFill>
+                  </a:tcPr>
+                </a:tc>
+                <a:tc>
+                  <a:txBody>
+                    <a:bodyPr/>
+                    <a:lstStyle/>
+                    <a:p>
+                      <a:pPr algn="ctr" indent="0" marL="0">
+                        <a:lnSpc>
+                          <a:spcPts val="3060"/>
+                        </a:lnSpc>
+                        <a:buNone/>
+                      </a:pPr>
+                      <a:r>
+                        <a:rPr lang="en-US" sz="2550" dirty="0" spc="-1" kern="0">
+                          <a:solidFill>
+                            <a:srgbClr val="14161C"/>
+                          </a:solidFill>
+                          <a:latin typeface="Be Vietnam Pro" pitchFamily="34" charset="0"/>
+                          <a:ea typeface="Be Vietnam Pro" pitchFamily="34" charset="-122"/>
+                          <a:cs typeface="Be Vietnam Pro" pitchFamily="34" charset="-120"/>
+                        </a:rPr>
+                        <a:t>?</a:t>
+                      </a:r>
+                      <a:endParaRPr lang="en-US" sz="1200" dirty="0"/>
+                    </a:p>
+                  </a:txBody>
+                  <a:tcPr marL="76200" marR="76200" marT="76200" marB="76200" anchor="ctr">
+                    <a:lnL w="19050" cap="flat" cmpd="sng" algn="ctr">
+                      <a:solidFill>
+                        <a:srgbClr val="DDD5C1"/>
+                      </a:solidFill>
+                      <a:prstDash val="solid"/>
+                      <a:round/>
+                      <a:headEnd type="none" w="med" len="med"/>
+                      <a:tailEnd type="none" w="med" len="med"/>
+                    </a:lnL>
+                    <a:lnR w="0" cap="flat" cmpd="sng" algn="ctr">
+                      <a:noFill/>
+                    </a:lnR>
+                    <a:lnT w="19050" cap="flat" cmpd="sng" algn="ctr">
+                      <a:solidFill>
+                        <a:srgbClr val="DDD5C1"/>
+                      </a:solidFill>
+                      <a:prstDash val="solid"/>
+                      <a:round/>
+                      <a:headEnd type="none" w="med" len="med"/>
+                      <a:tailEnd type="none" w="med" len="med"/>
+                    </a:lnT>
+                    <a:lnB w="0" cap="flat" cmpd="sng" algn="ctr">
+                      <a:noFill/>
+                    </a:lnB>
+                    <a:solidFill>
+                      <a:srgbClr val="FBF8F2"/>
+                    </a:solidFill>
+                  </a:tcPr>
+                </a:tc>
+                <a:tc>
+                  <a:txBody>
+                    <a:bodyPr/>
+                    <a:lstStyle/>
+                    <a:p>
+                      <a:pPr algn="ctr" indent="0" marL="0">
+                        <a:lnSpc>
+                          <a:spcPts val="3060"/>
+                        </a:lnSpc>
+                        <a:buNone/>
+                      </a:pPr>
+                      <a:r>
+                        <a:rPr lang="en-US" sz="2550" dirty="0" spc="-1" kern="0">
+                          <a:solidFill>
+                            <a:srgbClr val="14161C"/>
+                          </a:solidFill>
+                          <a:latin typeface="Be Vietnam Pro" pitchFamily="34" charset="0"/>
+                          <a:ea typeface="Be Vietnam Pro" pitchFamily="34" charset="-122"/>
+                          <a:cs typeface="Be Vietnam Pro" pitchFamily="34" charset="-120"/>
+                        </a:rPr>
+                        <a:t>?</a:t>
+                      </a:r>
+                      <a:endParaRPr lang="en-US" sz="1200" dirty="0"/>
+                    </a:p>
+                  </a:txBody>
+                  <a:tcPr marL="76200" marR="76200" marT="76200" marB="76200" anchor="ctr">
+                    <a:lnL w="19050" cap="flat" cmpd="sng" algn="ctr">
+                      <a:solidFill>
+                        <a:srgbClr val="DDD5C1"/>
+                      </a:solidFill>
+                      <a:prstDash val="solid"/>
+                      <a:round/>
+                      <a:headEnd type="none" w="med" len="med"/>
+                      <a:tailEnd type="none" w="med" len="med"/>
+                    </a:lnL>
+                    <a:lnR w="0" cap="flat" cmpd="sng" algn="ctr">
+                      <a:noFill/>
+                    </a:lnR>
+                    <a:lnT w="19050" cap="flat" cmpd="sng" algn="ctr">
+                      <a:solidFill>
+                        <a:srgbClr val="DDD5C1"/>
+                      </a:solidFill>
+                      <a:prstDash val="solid"/>
+                      <a:round/>
+                      <a:headEnd type="none" w="med" len="med"/>
+                      <a:tailEnd type="none" w="med" len="med"/>
+                    </a:lnT>
+                    <a:lnB w="0" cap="flat" cmpd="sng" algn="ctr">
+                      <a:noFill/>
+                    </a:lnB>
+                    <a:solidFill>
+                      <a:srgbClr val="FBF8F2"/>
+                    </a:solidFill>
+                  </a:tcPr>
+                </a:tc>
+              </a:tr>
             </a:tbl>
           </a:graphicData>
         </a:graphic>
@@ -8330,7 +8385,7 @@
               <a:buNone/>
             </a:pPr>
             <a:r>
-              <a:rPr lang="en-US" sz="30000" dirty="0" kern="0">
+              <a:rPr lang="en-US" sz="30000" dirty="0" spc="-3" kern="0">
                 <a:solidFill>
                   <a:srgbClr val="3DD6A0"/>
                 </a:solidFill>
@@ -8338,7 +8393,7 @@
                 <a:ea typeface="Bricolage Grotesque ExtraBold" pitchFamily="34" charset="-122"/>
                 <a:cs typeface="Bricolage Grotesque ExtraBold" pitchFamily="34" charset="-120"/>
               </a:rPr>
-              <a:t>1</a:t>
+              <a:t>4</a:t>
             </a:r>
             <a:endParaRPr lang="en-US" sz="30000" dirty="0"/>
           </a:p>
@@ -8369,7 +8424,7 @@
               <a:buNone/>
             </a:pPr>
             <a:r>
-              <a:rPr lang="en-US" sz="3600" b="1" dirty="0" spc="1" kern="0">
+              <a:rPr lang="en-US" sz="3600" b="1" dirty="0" spc="-26" kern="0">
                 <a:solidFill>
                   <a:srgbClr val="F3EEE3"/>
                 </a:solidFill>
@@ -8377,10 +8432,10 @@
                 <a:ea typeface="Be Vietnam Pro" pitchFamily="34" charset="-122"/>
                 <a:cs typeface="Be Vietnam Pro" pitchFamily="34" charset="-120"/>
               </a:rPr>
-              <a:t>cụm</a:t>
-            </a:r>
-            <a:r>
-              <a:rPr lang="en-US" sz="3600" b="1" dirty="0" spc="2" kern="0">
+              <a:t>trên</a:t>
+            </a:r>
+            <a:r>
+              <a:rPr lang="en-US" sz="3600" b="1" dirty="0" spc="5" kern="0">
                 <a:solidFill>
                   <a:srgbClr val="F3EEE3"/>
                 </a:solidFill>
@@ -8388,7 +8443,18 @@
                 <a:ea typeface="Be Vietnam Pro" pitchFamily="34" charset="-122"/>
                 <a:cs typeface="Be Vietnam Pro" pitchFamily="34" charset="-120"/>
               </a:rPr>
-              <a:t> thử</a:t>
+              <a:t> 5</a:t>
+            </a:r>
+            <a:r>
+              <a:rPr lang="en-US" sz="3600" b="1" dirty="0" spc="17" kern="0">
+                <a:solidFill>
+                  <a:srgbClr val="F3EEE3"/>
+                </a:solidFill>
+                <a:latin typeface="Be Vietnam Pro" pitchFamily="34" charset="0"/>
+                <a:ea typeface="Be Vietnam Pro" pitchFamily="34" charset="-122"/>
+                <a:cs typeface="Be Vietnam Pro" pitchFamily="34" charset="-120"/>
+              </a:rPr>
+              <a:t> bước</a:t>
             </a:r>
             <a:endParaRPr lang="en-US" sz="3600" dirty="0"/>
           </a:p>
@@ -8413,9 +8479,9 @@
           <a:solidFill>
             <a:srgbClr val="1E212B"/>
           </a:solidFill>
-          <a:ln w="28575">
+          <a:ln w="19050">
             <a:solidFill>
-              <a:srgbClr val="3DD6A0"/>
+              <a:srgbClr val="3A3F4D"/>
             </a:solidFill>
             <a:prstDash val="solid"/>
           </a:ln>
@@ -8429,50 +8495,8 @@
         </p:nvSpPr>
         <p:spPr>
           <a:xfrm>
-            <a:off x="9848850" y="3143250"/>
-            <a:ext cx="7048500" cy="4000500"/>
-          </a:xfrm>
-          <a:prstGeom prst="rect">
-            <a:avLst/>
-          </a:prstGeom>
-          <a:noFill/>
-          <a:ln/>
-        </p:spPr>
-        <p:txBody>
-          <a:bodyPr wrap="square" lIns="0" tIns="304800" rIns="0" bIns="-304800" rtlCol="0" anchor="t"/>
-          <a:lstStyle/>
-          <a:p>
-            <a:pPr algn="ctr" indent="0" marL="0">
-              <a:lnSpc>
-                <a:spcPts val="30000"/>
-              </a:lnSpc>
-              <a:buNone/>
-            </a:pPr>
-            <a:r>
-              <a:rPr lang="en-US" sz="30000" dirty="0" kern="0">
-                <a:solidFill>
-                  <a:srgbClr val="3DD6A0"/>
-                </a:solidFill>
-                <a:latin typeface="Bricolage Grotesque ExtraBold" pitchFamily="34" charset="0"/>
-                <a:ea typeface="Bricolage Grotesque ExtraBold" pitchFamily="34" charset="-122"/>
-                <a:cs typeface="Bricolage Grotesque ExtraBold" pitchFamily="34" charset="-120"/>
-              </a:rPr>
-              <a:t>1</a:t>
-            </a:r>
-            <a:endParaRPr lang="en-US" sz="30000" dirty="0"/>
-          </a:p>
-        </p:txBody>
-      </p:sp>
-      <p:sp>
-        <p:nvSpPr>
-          <p:cNvPr id="9" name="Text 7"/>
-          <p:cNvSpPr/>
-          <p:nvPr/>
-        </p:nvSpPr>
-        <p:spPr>
-          <a:xfrm>
-            <a:off x="9848850" y="7429500"/>
-            <a:ext cx="7048500" cy="666750"/>
+            <a:off x="9848850" y="3619500"/>
+            <a:ext cx="7048500" cy="419100"/>
           </a:xfrm>
           <a:prstGeom prst="rect">
             <a:avLst/>
@@ -8484,43 +8508,151 @@
           <a:bodyPr wrap="square" lIns="0" tIns="0" rIns="0" bIns="0" rtlCol="0" anchor="t"/>
           <a:lstStyle/>
           <a:p>
-            <a:pPr algn="ctr" indent="0" marL="0">
+            <a:pPr algn="l" indent="0" marL="0">
               <a:buNone/>
             </a:pPr>
             <a:r>
-              <a:rPr lang="en-US" sz="3600" b="1" dirty="0" spc="-11" kern="0">
+              <a:rPr lang="en-US" sz="2100" b="1" spc="152" kern="0" dirty="0">
+                <a:solidFill>
+                  <a:srgbClr val="9AA0B5"/>
+                </a:solidFill>
+                <a:latin typeface="Be Vietnam Pro" pitchFamily="34" charset="0"/>
+                <a:ea typeface="Be Vietnam Pro" pitchFamily="34" charset="-122"/>
+                <a:cs typeface="Be Vietnam Pro" pitchFamily="34" charset="-120"/>
+              </a:rPr>
+              <a:t>THỨ</a:t>
+            </a:r>
+            <a:r>
+              <a:rPr lang="en-US" sz="2100" b="1" spc="151" kern="0" dirty="0">
+                <a:solidFill>
+                  <a:srgbClr val="9AA0B5"/>
+                </a:solidFill>
+                <a:latin typeface="Be Vietnam Pro" pitchFamily="34" charset="0"/>
+                <a:ea typeface="Be Vietnam Pro" pitchFamily="34" charset="-122"/>
+                <a:cs typeface="Be Vietnam Pro" pitchFamily="34" charset="-120"/>
+              </a:rPr>
+              <a:t> TỰ</a:t>
+            </a:r>
+            <a:endParaRPr lang="en-US" sz="2100" dirty="0"/>
+          </a:p>
+        </p:txBody>
+      </p:sp>
+      <p:sp>
+        <p:nvSpPr>
+          <p:cNvPr id="9" name="Text 7"/>
+          <p:cNvSpPr/>
+          <p:nvPr/>
+        </p:nvSpPr>
+        <p:spPr>
+          <a:xfrm>
+            <a:off x="9848850" y="4381500"/>
+            <a:ext cx="7048500" cy="2857500"/>
+          </a:xfrm>
+          <a:prstGeom prst="rect">
+            <a:avLst/>
+          </a:prstGeom>
+          <a:noFill/>
+          <a:ln/>
+        </p:spPr>
+        <p:txBody>
+          <a:bodyPr wrap="square" lIns="0" tIns="15240" rIns="0" bIns="-15240" rtlCol="0" anchor="t"/>
+          <a:lstStyle/>
+          <a:p>
+            <a:pPr algn="l" indent="0" marL="0">
+              <a:lnSpc>
+                <a:spcPts val="5520"/>
+              </a:lnSpc>
+              <a:buNone/>
+            </a:pPr>
+            <a:r>
+              <a:rPr lang="en-US" sz="4800" dirty="0" spc="2" kern="0">
                 <a:solidFill>
                   <a:srgbClr val="F3EEE3"/>
                 </a:solidFill>
-                <a:latin typeface="Be Vietnam Pro" pitchFamily="34" charset="0"/>
-                <a:ea typeface="Be Vietnam Pro" pitchFamily="34" charset="-122"/>
-                <a:cs typeface="Be Vietnam Pro" pitchFamily="34" charset="-120"/>
-              </a:rPr>
-              <a:t>nhóm</a:t>
-            </a:r>
-            <a:r>
-              <a:rPr lang="en-US" sz="3600" b="1" dirty="0" spc="-3" kern="0">
+                <a:latin typeface="Bricolage Grotesque ExtraBold" pitchFamily="34" charset="0"/>
+                <a:ea typeface="Bricolage Grotesque ExtraBold" pitchFamily="34" charset="-122"/>
+                <a:cs typeface="Bricolage Grotesque ExtraBold" pitchFamily="34" charset="-120"/>
+              </a:rPr>
+              <a:t>Thử</a:t>
+            </a:r>
+            <a:r>
+              <a:rPr lang="en-US" sz="4800" dirty="0" spc="-16" kern="0">
                 <a:solidFill>
                   <a:srgbClr val="F3EEE3"/>
                 </a:solidFill>
-                <a:latin typeface="Be Vietnam Pro" pitchFamily="34" charset="0"/>
-                <a:ea typeface="Be Vietnam Pro" pitchFamily="34" charset="-122"/>
-                <a:cs typeface="Be Vietnam Pro" pitchFamily="34" charset="-120"/>
-              </a:rPr>
-              <a:t> dùng</a:t>
-            </a:r>
-            <a:r>
-              <a:rPr lang="en-US" sz="3600" b="1" dirty="0" spc="2" kern="0">
+                <a:latin typeface="Bricolage Grotesque ExtraBold" pitchFamily="34" charset="0"/>
+                <a:ea typeface="Bricolage Grotesque ExtraBold" pitchFamily="34" charset="-122"/>
+                <a:cs typeface="Bricolage Grotesque ExtraBold" pitchFamily="34" charset="-120"/>
+              </a:rPr>
+              <a:t> nhỏ,</a:t>
+            </a:r>
+            <a:r>
+              <a:rPr lang="en-US" sz="4800" dirty="0" spc="-17" kern="0">
                 <a:solidFill>
                   <a:srgbClr val="F3EEE3"/>
                 </a:solidFill>
-                <a:latin typeface="Be Vietnam Pro" pitchFamily="34" charset="0"/>
-                <a:ea typeface="Be Vietnam Pro" pitchFamily="34" charset="-122"/>
-                <a:cs typeface="Be Vietnam Pro" pitchFamily="34" charset="-120"/>
-              </a:rPr>
-              <a:t> thử</a:t>
-            </a:r>
-            <a:endParaRPr lang="en-US" sz="3600" dirty="0"/>
+                <a:latin typeface="Bricolage Grotesque ExtraBold" pitchFamily="34" charset="0"/>
+                <a:ea typeface="Bricolage Grotesque ExtraBold" pitchFamily="34" charset="-122"/>
+                <a:cs typeface="Bricolage Grotesque ExtraBold" pitchFamily="34" charset="-120"/>
+              </a:rPr>
+              <a:t> rồi</a:t>
+            </a:r>
+            <a:r>
+              <a:rPr lang="en-US" sz="4800" dirty="0" spc="-23" kern="0">
+                <a:solidFill>
+                  <a:srgbClr val="F3EEE3"/>
+                </a:solidFill>
+                <a:latin typeface="Bricolage Grotesque ExtraBold" pitchFamily="34" charset="0"/>
+                <a:ea typeface="Bricolage Grotesque ExtraBold" pitchFamily="34" charset="-122"/>
+                <a:cs typeface="Bricolage Grotesque ExtraBold" pitchFamily="34" charset="-120"/>
+              </a:rPr>
+              <a:t> mới</a:t>
+            </a:r>
+            <a:r>
+              <a:rPr lang="en-US" sz="4800" dirty="0" spc="-2" kern="0">
+                <a:solidFill>
+                  <a:srgbClr val="F3EEE3"/>
+                </a:solidFill>
+                <a:latin typeface="Bricolage Grotesque ExtraBold" pitchFamily="34" charset="0"/>
+                <a:ea typeface="Bricolage Grotesque ExtraBold" pitchFamily="34" charset="-122"/>
+                <a:cs typeface="Bricolage Grotesque ExtraBold" pitchFamily="34" charset="-120"/>
+              </a:rPr>
+              <a:t> ghi</a:t>
+            </a:r>
+            <a:r>
+              <a:rPr lang="en-US" sz="4800" dirty="0" spc="-3" kern="0">
+                <a:solidFill>
+                  <a:srgbClr val="F3EEE3"/>
+                </a:solidFill>
+                <a:latin typeface="Bricolage Grotesque ExtraBold" pitchFamily="34" charset="0"/>
+                <a:ea typeface="Bricolage Grotesque ExtraBold" pitchFamily="34" charset="-122"/>
+                <a:cs typeface="Bricolage Grotesque ExtraBold" pitchFamily="34" charset="-120"/>
+              </a:rPr>
+              <a:t> lại</a:t>
+            </a:r>
+            <a:r>
+              <a:rPr lang="en-US" sz="4800" dirty="0" spc="2" kern="0">
+                <a:solidFill>
+                  <a:srgbClr val="F3EEE3"/>
+                </a:solidFill>
+                <a:latin typeface="Bricolage Grotesque ExtraBold" pitchFamily="34" charset="0"/>
+                <a:ea typeface="Bricolage Grotesque ExtraBold" pitchFamily="34" charset="-122"/>
+                <a:cs typeface="Bricolage Grotesque ExtraBold" pitchFamily="34" charset="-120"/>
+              </a:rPr>
+              <a:t> quyết</a:t>
+            </a:r>
+            <a:r>
+              <a:rPr lang="en-US" sz="4800" dirty="0" spc="12" kern="0">
+                <a:solidFill>
+                  <a:srgbClr val="F3EEE3"/>
+                </a:solidFill>
+                <a:latin typeface="Bricolage Grotesque ExtraBold" pitchFamily="34" charset="0"/>
+                <a:ea typeface="Bricolage Grotesque ExtraBold" pitchFamily="34" charset="-122"/>
+                <a:cs typeface="Bricolage Grotesque ExtraBold" pitchFamily="34" charset="-120"/>
+              </a:rPr>
+              <a:t> định.</a:t>
+            </a:r>
+            <a:endParaRPr lang="en-US" sz="4800" dirty="0"/>
           </a:p>
         </p:txBody>
       </p:sp>
@@ -9144,7 +9276,7 @@
               <a:buNone/>
             </a:pPr>
             <a:r>
-              <a:rPr lang="en-US" sz="3740" dirty="0" spc="-19" kern="0">
+              <a:rPr lang="en-US" sz="3750" dirty="0" spc="-1" kern="0">
                 <a:solidFill>
                   <a:srgbClr val="E8472B"/>
                 </a:solidFill>
@@ -9152,10 +9284,10 @@
                 <a:ea typeface="Bricolage Grotesque ExtraBold" pitchFamily="34" charset="-122"/>
                 <a:cs typeface="Bricolage Grotesque ExtraBold" pitchFamily="34" charset="-120"/>
               </a:rPr>
-              <a:t>Lý</a:t>
-            </a:r>
-            <a:r>
-              <a:rPr lang="en-US" sz="3740" dirty="0" spc="-1" kern="0">
+              <a:t>Công cụ</a:t>
+            </a:r>
+            <a:r>
+              <a:rPr lang="en-US" sz="3750" dirty="0" spc="8" kern="0">
                 <a:solidFill>
                   <a:srgbClr val="E8472B"/>
                 </a:solidFill>
@@ -9163,10 +9295,10 @@
                 <a:ea typeface="Bricolage Grotesque ExtraBold" pitchFamily="34" charset="-122"/>
                 <a:cs typeface="Bricolage Grotesque ExtraBold" pitchFamily="34" charset="-120"/>
               </a:rPr>
-              <a:t> do</a:t>
-            </a:r>
-            <a:r>
-              <a:rPr lang="en-US" sz="3740" dirty="0" spc="0" kern="0">
+              <a:t> đã</a:t>
+            </a:r>
+            <a:r>
+              <a:rPr lang="en-US" sz="3750" dirty="0" spc="-3" kern="0">
                 <a:solidFill>
                   <a:srgbClr val="E8472B"/>
                 </a:solidFill>
@@ -9176,7 +9308,7 @@
               </a:rPr>
               <a:t> chọn</a:t>
             </a:r>
-            <a:endParaRPr lang="en-US" sz="3740" dirty="0"/>
+            <a:endParaRPr lang="en-US" sz="3750" dirty="0"/>
           </a:p>
         </p:txBody>
       </p:sp>
@@ -9354,7 +9486,7 @@
               <a:buNone/>
             </a:pPr>
             <a:r>
-              <a:rPr lang="en-US" sz="3740" dirty="0" spc="3" kern="0">
+              <a:rPr lang="en-US" sz="3750" dirty="0" spc="-21" kern="0">
                 <a:solidFill>
                   <a:srgbClr val="E8472B"/>
                 </a:solidFill>
@@ -9362,10 +9494,10 @@
                 <a:ea typeface="Bricolage Grotesque ExtraBold" pitchFamily="34" charset="-122"/>
                 <a:cs typeface="Bricolage Grotesque ExtraBold" pitchFamily="34" charset="-120"/>
               </a:rPr>
-              <a:t>Điều</a:t>
-            </a:r>
-            <a:r>
-              <a:rPr lang="en-US" sz="3740" dirty="0" spc="0" kern="0">
+              <a:t>Lý</a:t>
+            </a:r>
+            <a:r>
+              <a:rPr lang="en-US" sz="3750" dirty="0" spc="-1" kern="0">
                 <a:solidFill>
                   <a:srgbClr val="E8472B"/>
                 </a:solidFill>
@@ -9373,10 +9505,10 @@
                 <a:ea typeface="Bricolage Grotesque ExtraBold" pitchFamily="34" charset="-122"/>
                 <a:cs typeface="Bricolage Grotesque ExtraBold" pitchFamily="34" charset="-120"/>
               </a:rPr>
-              <a:t> kiện</a:t>
-            </a:r>
-            <a:r>
-              <a:rPr lang="en-US" sz="3740" dirty="0" spc="-43" kern="0">
+              <a:t> do</a:t>
+            </a:r>
+            <a:r>
+              <a:rPr lang="en-US" sz="3750" dirty="0" spc="-3" kern="0">
                 <a:solidFill>
                   <a:srgbClr val="E8472B"/>
                 </a:solidFill>
@@ -9384,20 +9516,9 @@
                 <a:ea typeface="Bricolage Grotesque ExtraBold" pitchFamily="34" charset="-122"/>
                 <a:cs typeface="Bricolage Grotesque ExtraBold" pitchFamily="34" charset="-120"/>
               </a:rPr>
-              <a:t> xem</a:t>
-            </a:r>
-            <a:r>
-              <a:rPr lang="en-US" sz="3740" dirty="0" spc="1" kern="0">
-                <a:solidFill>
-                  <a:srgbClr val="E8472B"/>
-                </a:solidFill>
-                <a:latin typeface="Bricolage Grotesque ExtraBold" pitchFamily="34" charset="0"/>
-                <a:ea typeface="Bricolage Grotesque ExtraBold" pitchFamily="34" charset="-122"/>
-                <a:cs typeface="Bricolage Grotesque ExtraBold" pitchFamily="34" charset="-120"/>
-              </a:rPr>
-              <a:t> lại</a:t>
-            </a:r>
-            <a:endParaRPr lang="en-US" sz="3740" dirty="0"/>
+              <a:t> chọn</a:t>
+            </a:r>
+            <a:endParaRPr lang="en-US" sz="3750" dirty="0"/>
           </a:p>
         </p:txBody>
       </p:sp>

</xml_diff>